<commit_message>
Flaecheninhalt-Zusammenfassung: Akzentfarbe Gelb durch Cleverbox-Neongruen ersetzt
Co-Authored-By: Claude Sonnet 5.5 <noreply@anthropic.com>
Claude-Session: https://claude.ai/code/session_0139kriXJ67p3UvpR2gsSR9G
</commit_message>
<xml_diff>
--- a/videoslides/flaecheninhalt-zusammenfassung-a4.pptx
+++ b/videoslides/flaecheninhalt-zusammenfassung-a4.pptx
@@ -900,7 +900,7 @@
     <p:bg>
       <p:bgPr>
         <a:solidFill>
-          <a:srgbClr val="FFD84D"/>
+          <a:srgbClr val="B1FF37"/>
         </a:solidFill>
       </p:bgPr>
     </p:bg>
@@ -1352,7 +1352,7 @@
                   <a:srgbClr val="1F5FBF"/>
                 </a:solidFill>
                 <a:highlight>
-                  <a:srgbClr val="FFD84D"/>
+                  <a:srgbClr val="B1FF37"/>
                 </a:highlight>
                 <a:latin typeface="Poppins" pitchFamily="34" charset="0"/>
                 <a:ea typeface="Poppins" pitchFamily="34" charset="-122"/>
@@ -1418,7 +1418,7 @@
             <a:r>
               <a:rPr lang="en-US" sz="1500" b="1" dirty="0">
                 <a:solidFill>
-                  <a:srgbClr val="FFD84D"/>
+                  <a:srgbClr val="B1FF37"/>
                 </a:solidFill>
                 <a:latin typeface="Poppins" pitchFamily="34" charset="0"/>
                 <a:ea typeface="Poppins" pitchFamily="34" charset="-122"/>
@@ -2249,11 +2249,11 @@
             </a:avLst>
           </a:prstGeom>
           <a:solidFill>
-            <a:srgbClr val="FFD84D"/>
+            <a:srgbClr val="B1FF37"/>
           </a:solidFill>
           <a:ln w="15875">
             <a:solidFill>
-              <a:srgbClr val="FFD84D"/>
+              <a:srgbClr val="B1FF37"/>
             </a:solidFill>
             <a:prstDash val="solid"/>
           </a:ln>
@@ -2474,7 +2474,7 @@
                   <a:srgbClr val="1F5FBF"/>
                 </a:solidFill>
                 <a:highlight>
-                  <a:srgbClr val="FFD84D"/>
+                  <a:srgbClr val="B1FF37"/>
                 </a:highlight>
                 <a:latin typeface="Poppins" pitchFamily="34" charset="0"/>
                 <a:ea typeface="Poppins" pitchFamily="34" charset="-122"/>
@@ -2690,7 +2690,7 @@
             <a:r>
               <a:rPr lang="en-US" sz="1050" b="1" dirty="0">
                 <a:solidFill>
-                  <a:srgbClr val="FFD84D"/>
+                  <a:srgbClr val="B1FF37"/>
                 </a:solidFill>
                 <a:latin typeface="Poppins" pitchFamily="34" charset="0"/>
                 <a:ea typeface="Poppins" pitchFamily="34" charset="-122"/>
@@ -2744,7 +2744,7 @@
             <a:avLst/>
           </a:prstGeom>
           <a:solidFill>
-            <a:srgbClr val="FFD84D"/>
+            <a:srgbClr val="B1FF37"/>
           </a:solidFill>
           <a:ln w="19050">
             <a:solidFill>
@@ -2889,7 +2889,7 @@
             <a:r>
               <a:rPr lang="en-US" sz="1050" b="1" dirty="0">
                 <a:solidFill>
-                  <a:srgbClr val="FFD84D"/>
+                  <a:srgbClr val="B1FF37"/>
                 </a:solidFill>
                 <a:latin typeface="Poppins" pitchFamily="34" charset="0"/>
                 <a:ea typeface="Poppins" pitchFamily="34" charset="-122"/>
@@ -3088,7 +3088,7 @@
             <a:r>
               <a:rPr lang="en-US" sz="1050" b="1" dirty="0">
                 <a:solidFill>
-                  <a:srgbClr val="FFD84D"/>
+                  <a:srgbClr val="B1FF37"/>
                 </a:solidFill>
                 <a:latin typeface="Poppins" pitchFamily="34" charset="0"/>
                 <a:ea typeface="Poppins" pitchFamily="34" charset="-122"/>
@@ -3142,7 +3142,7 @@
             <a:avLst/>
           </a:prstGeom>
           <a:solidFill>
-            <a:srgbClr val="FFD84D"/>
+            <a:srgbClr val="B1FF37"/>
           </a:solidFill>
           <a:ln w="19050">
             <a:solidFill>
@@ -3287,7 +3287,7 @@
             <a:r>
               <a:rPr lang="en-US" sz="1050" b="1" dirty="0">
                 <a:solidFill>
-                  <a:srgbClr val="FFD84D"/>
+                  <a:srgbClr val="B1FF37"/>
                 </a:solidFill>
                 <a:latin typeface="Poppins" pitchFamily="34" charset="0"/>
                 <a:ea typeface="Poppins" pitchFamily="34" charset="-122"/>
@@ -3301,7 +3301,7 @@
             <a:r>
               <a:rPr lang="en-US" sz="1050" b="1" dirty="0">
                 <a:solidFill>
-                  <a:srgbClr val="FFD84D"/>
+                  <a:srgbClr val="B1FF37"/>
                 </a:solidFill>
                 <a:latin typeface="Poppins" pitchFamily="34" charset="0"/>
                 <a:ea typeface="Poppins" pitchFamily="34" charset="-122"/>
@@ -3315,7 +3315,7 @@
             <a:r>
               <a:rPr lang="en-US" sz="1050" b="1" baseline="-40000" dirty="0">
                 <a:solidFill>
-                  <a:srgbClr val="FFD84D"/>
+                  <a:srgbClr val="B1FF37"/>
                 </a:solidFill>
                 <a:latin typeface="Poppins" pitchFamily="34" charset="0"/>
                 <a:ea typeface="Poppins" pitchFamily="34" charset="-122"/>
@@ -3354,7 +3354,7 @@
             <a:r>
               <a:rPr lang="en-US" sz="1050" b="1" dirty="0">
                 <a:solidFill>
-                  <a:srgbClr val="FFD84D"/>
+                  <a:srgbClr val="B1FF37"/>
                 </a:solidFill>
                 <a:latin typeface="Poppins" pitchFamily="34" charset="0"/>
                 <a:ea typeface="Poppins" pitchFamily="34" charset="-122"/>
@@ -3368,7 +3368,7 @@
             <a:r>
               <a:rPr lang="en-US" sz="1050" b="1" dirty="0">
                 <a:solidFill>
-                  <a:srgbClr val="FFD84D"/>
+                  <a:srgbClr val="B1FF37"/>
                 </a:solidFill>
                 <a:latin typeface="Poppins" pitchFamily="34" charset="0"/>
                 <a:ea typeface="Poppins" pitchFamily="34" charset="-122"/>
@@ -3382,7 +3382,7 @@
             <a:r>
               <a:rPr lang="en-US" sz="1050" b="1" baseline="-40000" dirty="0">
                 <a:solidFill>
-                  <a:srgbClr val="FFD84D"/>
+                  <a:srgbClr val="B1FF37"/>
                 </a:solidFill>
                 <a:latin typeface="Poppins" pitchFamily="34" charset="0"/>
                 <a:ea typeface="Poppins" pitchFamily="34" charset="-122"/>
@@ -3581,7 +3581,7 @@
             <a:r>
               <a:rPr lang="en-US" sz="1050" b="1" dirty="0">
                 <a:solidFill>
-                  <a:srgbClr val="FFD84D"/>
+                  <a:srgbClr val="B1FF37"/>
                 </a:solidFill>
                 <a:latin typeface="Poppins" pitchFamily="34" charset="0"/>
                 <a:ea typeface="Poppins" pitchFamily="34" charset="-122"/>
@@ -3620,7 +3620,7 @@
             <a:r>
               <a:rPr lang="en-US" sz="1050" b="1" dirty="0">
                 <a:solidFill>
-                  <a:srgbClr val="FFD84D"/>
+                  <a:srgbClr val="B1FF37"/>
                 </a:solidFill>
                 <a:latin typeface="Poppins" pitchFamily="34" charset="0"/>
                 <a:ea typeface="Poppins" pitchFamily="34" charset="-122"/>
@@ -3674,7 +3674,7 @@
             <a:avLst/>
           </a:prstGeom>
           <a:solidFill>
-            <a:srgbClr val="FFD84D"/>
+            <a:srgbClr val="B1FF37"/>
           </a:solidFill>
           <a:ln w="19050">
             <a:solidFill>
@@ -3819,7 +3819,7 @@
             <a:r>
               <a:rPr lang="en-US" sz="1050" b="1" dirty="0">
                 <a:solidFill>
-                  <a:srgbClr val="FFD84D"/>
+                  <a:srgbClr val="B1FF37"/>
                 </a:solidFill>
                 <a:latin typeface="Poppins" pitchFamily="34" charset="0"/>
                 <a:ea typeface="Poppins" pitchFamily="34" charset="-122"/>
@@ -4039,7 +4039,7 @@
             <a:r>
               <a:rPr lang="en-US" sz="1050" b="1" dirty="0">
                 <a:solidFill>
-                  <a:srgbClr val="FFD84D"/>
+                  <a:srgbClr val="B1FF37"/>
                 </a:solidFill>
                 <a:latin typeface="Poppins" pitchFamily="34" charset="0"/>
                 <a:ea typeface="Poppins" pitchFamily="34" charset="-122"/>
@@ -4093,7 +4093,7 @@
             <a:avLst/>
           </a:prstGeom>
           <a:solidFill>
-            <a:srgbClr val="FFD84D"/>
+            <a:srgbClr val="B1FF37"/>
           </a:solidFill>
           <a:ln w="19050">
             <a:solidFill>
@@ -4340,7 +4340,7 @@
             <a:r>
               <a:rPr lang="en-US" sz="1050" b="1" dirty="0">
                 <a:solidFill>
-                  <a:srgbClr val="FFD84D"/>
+                  <a:srgbClr val="B1FF37"/>
                 </a:solidFill>
                 <a:latin typeface="Poppins" pitchFamily="34" charset="0"/>
                 <a:ea typeface="Poppins" pitchFamily="34" charset="-122"/>
@@ -4354,7 +4354,7 @@
             <a:r>
               <a:rPr lang="en-US" sz="1050" b="1" dirty="0">
                 <a:solidFill>
-                  <a:srgbClr val="FFD84D"/>
+                  <a:srgbClr val="B1FF37"/>
                 </a:solidFill>
                 <a:latin typeface="Poppins" pitchFamily="34" charset="0"/>
                 <a:ea typeface="Poppins" pitchFamily="34" charset="-122"/>
@@ -4368,7 +4368,7 @@
             <a:r>
               <a:rPr lang="en-US" sz="1050" b="1" baseline="-40000" dirty="0">
                 <a:solidFill>
-                  <a:srgbClr val="FFD84D"/>
+                  <a:srgbClr val="B1FF37"/>
                 </a:solidFill>
                 <a:latin typeface="Poppins" pitchFamily="34" charset="0"/>
                 <a:ea typeface="Poppins" pitchFamily="34" charset="-122"/>
@@ -4382,7 +4382,7 @@
             <a:r>
               <a:rPr lang="en-US" sz="1050" b="1" dirty="0">
                 <a:solidFill>
-                  <a:srgbClr val="FFD84D"/>
+                  <a:srgbClr val="B1FF37"/>
                 </a:solidFill>
                 <a:latin typeface="Poppins" pitchFamily="34" charset="0"/>
                 <a:ea typeface="Poppins" pitchFamily="34" charset="-122"/>
@@ -4446,7 +4446,7 @@
             <a:r>
               <a:rPr lang="en-US" sz="1800" b="1" dirty="0">
                 <a:solidFill>
-                  <a:srgbClr val="FFD84D"/>
+                  <a:srgbClr val="B1FF37"/>
                 </a:solidFill>
                 <a:latin typeface="Poppins" pitchFamily="34" charset="0"/>
                 <a:ea typeface="Poppins" pitchFamily="34" charset="-122"/>
@@ -4506,7 +4506,7 @@
             <a:r>
               <a:rPr lang="en-US" sz="3800" dirty="0">
                 <a:solidFill>
-                  <a:srgbClr val="FFD84D"/>
+                  <a:srgbClr val="B1FF37"/>
                 </a:solidFill>
                 <a:latin typeface="Poppins" pitchFamily="34" charset="0"/>
                 <a:ea typeface="Poppins" pitchFamily="34" charset="-122"/>
@@ -4572,7 +4572,7 @@
             <a:r>
               <a:rPr lang="en-US" sz="1400" b="1" dirty="0">
                 <a:solidFill>
-                  <a:srgbClr val="FFD84D"/>
+                  <a:srgbClr val="B1FF37"/>
                 </a:solidFill>
                 <a:latin typeface="Poppins" pitchFamily="34" charset="0"/>
                 <a:ea typeface="Poppins" pitchFamily="34" charset="-122"/>
@@ -4782,7 +4782,7 @@
             <a:r>
               <a:rPr lang="en-US" sz="1400" b="1" dirty="0">
                 <a:solidFill>
-                  <a:srgbClr val="FFD84D"/>
+                  <a:srgbClr val="B1FF37"/>
                 </a:solidFill>
                 <a:latin typeface="Poppins" pitchFamily="34" charset="0"/>
                 <a:ea typeface="Poppins" pitchFamily="34" charset="-122"/>
@@ -4890,7 +4890,7 @@
             <a:r>
               <a:rPr lang="en-US" sz="1400" b="1" dirty="0">
                 <a:solidFill>
-                  <a:srgbClr val="FFD84D"/>
+                  <a:srgbClr val="B1FF37"/>
                 </a:solidFill>
                 <a:latin typeface="Poppins" pitchFamily="34" charset="0"/>
                 <a:ea typeface="Poppins" pitchFamily="34" charset="-122"/>
@@ -4998,7 +4998,7 @@
             <a:r>
               <a:rPr lang="en-US" sz="1400" b="1" dirty="0">
                 <a:solidFill>
-                  <a:srgbClr val="FFD84D"/>
+                  <a:srgbClr val="B1FF37"/>
                 </a:solidFill>
                 <a:latin typeface="Poppins" pitchFamily="34" charset="0"/>
                 <a:ea typeface="Poppins" pitchFamily="34" charset="-122"/>
@@ -5079,7 +5079,7 @@
             <a:r>
               <a:rPr lang="en-US" sz="2000" b="1" dirty="0">
                 <a:solidFill>
-                  <a:srgbClr val="FFD84D"/>
+                  <a:srgbClr val="B1FF37"/>
                 </a:solidFill>
                 <a:latin typeface="Poppins" pitchFamily="34" charset="0"/>
                 <a:ea typeface="Poppins" pitchFamily="34" charset="-122"/>
@@ -5133,11 +5133,11 @@
             <a:avLst/>
           </a:prstGeom>
           <a:solidFill>
-            <a:srgbClr val="FFD84D"/>
+            <a:srgbClr val="B1FF37"/>
           </a:solidFill>
           <a:ln w="12700">
             <a:solidFill>
-              <a:srgbClr val="FFD84D"/>
+              <a:srgbClr val="B1FF37"/>
             </a:solidFill>
             <a:prstDash val="solid"/>
           </a:ln>
@@ -5277,11 +5277,11 @@
             <a:avLst/>
           </a:prstGeom>
           <a:solidFill>
-            <a:srgbClr val="FFD84D"/>
+            <a:srgbClr val="B1FF37"/>
           </a:solidFill>
           <a:ln w="12700">
             <a:solidFill>
-              <a:srgbClr val="FFD84D"/>
+              <a:srgbClr val="B1FF37"/>
             </a:solidFill>
             <a:prstDash val="solid"/>
           </a:ln>
@@ -5421,11 +5421,11 @@
             <a:avLst/>
           </a:prstGeom>
           <a:solidFill>
-            <a:srgbClr val="FFD84D"/>
+            <a:srgbClr val="B1FF37"/>
           </a:solidFill>
           <a:ln w="12700">
             <a:solidFill>
-              <a:srgbClr val="FFD84D"/>
+              <a:srgbClr val="B1FF37"/>
             </a:solidFill>
             <a:prstDash val="solid"/>
           </a:ln>
@@ -5540,11 +5540,11 @@
             </a:avLst>
           </a:prstGeom>
           <a:solidFill>
-            <a:srgbClr val="FFD84D"/>
+            <a:srgbClr val="B1FF37"/>
           </a:solidFill>
           <a:ln w="15875">
             <a:solidFill>
-              <a:srgbClr val="FFD84D"/>
+              <a:srgbClr val="B1FF37"/>
             </a:solidFill>
             <a:prstDash val="solid"/>
           </a:ln>
@@ -5565,7 +5565,7 @@
             <a:avLst/>
           </a:prstGeom>
           <a:solidFill>
-            <a:srgbClr val="FFD84D"/>
+            <a:srgbClr val="B1FF37"/>
           </a:solidFill>
           <a:ln w="31750">
             <a:solidFill>

</xml_diff>